<commit_message>
Give the Day 3 student packet room: 3 pages -> 4
Theme test moves to p. 2 above the choice board; the Target Task response
continues onto p. 4 with the exit ticket. Writing spaces are larger.
Teacher copy and slides only get updated page references and thumbnails.

Co-Authored-By: Claude Opus 5.5 <noreply@anthropic.com>
Claude-Session: https://claude.ai/code/session_01VhJjhyYTBHwiMVyUj6jpKD
</commit_message>
<xml_diff>
--- a/lessons/week09/day3/Week9_Day3_Slides.pptx
+++ b/lessons/week09/day3/Week9_Day3_Slides.pptx
@@ -487,7 +487,7 @@
           </a:p>
           <a:p>
             <a:r>
-              <a:t>If your class submits on Course Mojo, scholars type there; p. 3 is the plan and backup.</a:t>
+              <a:t>If your class submits on Course Mojo, scholars type there; pp. 3-4 are the plan and backup.</a:t>
             </a:r>
           </a:p>
           <a:p>
@@ -497,7 +497,7 @@
           </a:p>
           <a:p>
             <a:r>
-              <a:t>Morehouse: point to the 'Need a start?' frame on p. 3; the response stays independent. Done early: stretch line on p. 3.</a:t>
+              <a:t>Morehouse: point to the 'Need a start?' frame on p. 3; the response stays independent. Done early: stretch line on p. 4.</a:t>
             </a:r>
           </a:p>
           <a:p>
@@ -507,7 +507,7 @@
           </a:p>
           <a:p>
             <a:r>
-              <a:t>TRANSITION: Pencils down. Find the dashed line on page 3. Exit ticket. On your own.</a:t>
+              <a:t>TRANSITION: Pencils down. Find the dashed line on page 4. Exit ticket. On your own.</a:t>
             </a:r>
           </a:p>
         </p:txBody>
@@ -1136,7 +1136,7 @@
           </a:p>
           <a:p>
             <a:r>
-              <a:t>TRANSITION: Those stay up. Before we analyze this ending in Course Mojo, I want you to sit with it for a few minutes. Page 2.</a:t>
+              <a:t>TRANSITION: Those stay up. Before we analyze this ending in Course Mojo, I want you to sit with it for a few minutes. Box 03, right below.</a:t>
             </a:r>
           </a:p>
         </p:txBody>
@@ -3393,7 +3393,7 @@
                 </a:solidFill>
                 <a:latin typeface="Century Gothic"/>
               </a:rPr>
-              <a:t>PACKET P. 3 · RESPONSE</a:t>
+              <a:t>PACKET PP. 3–4 · RESPONSE</a:t>
             </a:r>
           </a:p>
         </p:txBody>
@@ -4192,7 +4192,7 @@
                 </a:solidFill>
                 <a:latin typeface="Century Gothic"/>
               </a:rPr>
-              <a:t>PACKET P. 3 · BOX 05</a:t>
+              <a:t>PACKET P. 4 · BOX 05</a:t>
             </a:r>
           </a:p>
         </p:txBody>
@@ -10333,7 +10333,7 @@
                 </a:solidFill>
                 <a:latin typeface="Century Gothic"/>
               </a:rPr>
-              <a:t>PACKET P. 1 · BOX 02</a:t>
+              <a:t>PACKET P. 2 · THEME TEST</a:t>
             </a:r>
           </a:p>
         </p:txBody>

</xml_diff>

<commit_message>
Day 3 packet: larger print, open answer boxes, 5 pages
Body type goes from ~9pt to ~11.5pt (prompts ~13pt), ruled response
areas become plain boxes, and the packet reflows to 5 pages. Teacher copy
and slides get matching page references and thumbnails only. CLAUDE.md
records the readability-first and no-lines rules.

Co-Authored-By: Claude Opus 5.5 <noreply@anthropic.com>
Claude-Session: https://claude.ai/code/session_01VhJjhyYTBHwiMVyUj6jpKD
</commit_message>
<xml_diff>
--- a/lessons/week09/day3/Week9_Day3_Slides.pptx
+++ b/lessons/week09/day3/Week9_Day3_Slides.pptx
@@ -487,7 +487,7 @@
           </a:p>
           <a:p>
             <a:r>
-              <a:t>If your class submits on Course Mojo, scholars type there; pp. 3-4 are the plan and backup.</a:t>
+              <a:t>If your class submits on Course Mojo, scholars type there; p. 4 is the plan, p. 5 the backup.</a:t>
             </a:r>
           </a:p>
           <a:p>
@@ -497,7 +497,7 @@
           </a:p>
           <a:p>
             <a:r>
-              <a:t>Morehouse: point to the 'Need a start?' frame on p. 3; the response stays independent. Done early: stretch line on p. 4.</a:t>
+              <a:t>Morehouse: point to the 'Need a start?' frame on p. 4; the response stays independent. Done early: stretch line on p. 5.</a:t>
             </a:r>
           </a:p>
           <a:p>
@@ -507,7 +507,7 @@
           </a:p>
           <a:p>
             <a:r>
-              <a:t>TRANSITION: Pencils down. Find the dashed line on page 4. Exit ticket. On your own.</a:t>
+              <a:t>TRANSITION: Pencils down. Find the dashed line on page 5. Exit ticket. On your own.</a:t>
             </a:r>
           </a:p>
         </p:txBody>
@@ -1136,7 +1136,7 @@
           </a:p>
           <a:p>
             <a:r>
-              <a:t>TRANSITION: Those stay up. Before we analyze this ending in Course Mojo, I want you to sit with it for a few minutes. Box 03, right below.</a:t>
+              <a:t>TRANSITION: Those stay up. Before we analyze this ending in Course Mojo, I want you to sit with it for a few minutes. Page 3.</a:t>
             </a:r>
           </a:p>
         </p:txBody>
@@ -1214,7 +1214,7 @@
           </a:p>
           <a:p>
             <a:r>
-              <a:t>TRANSITION: Hold onto that feeling. Now we're going to prove what this ending does. Course Mojo, Lesson 6. Page 3. Sit with your partner.</a:t>
+              <a:t>TRANSITION: Hold onto that feeling. Now we're going to prove what this ending does. Course Mojo, Lesson 6. Page 4. Sit with your partner.</a:t>
             </a:r>
           </a:p>
         </p:txBody>
@@ -2661,7 +2661,7 @@
                 </a:solidFill>
                 <a:latin typeface="Century Gothic"/>
               </a:rPr>
-              <a:t>PACKET P. 3 · BOX 04</a:t>
+              <a:t>PACKET P. 4 · BOX 04</a:t>
             </a:r>
           </a:p>
         </p:txBody>
@@ -3393,7 +3393,7 @@
                 </a:solidFill>
                 <a:latin typeface="Century Gothic"/>
               </a:rPr>
-              <a:t>PACKET PP. 3–4 · RESPONSE</a:t>
+              <a:t>PACKET P. 5 · RESPONSE</a:t>
             </a:r>
           </a:p>
         </p:txBody>
@@ -4192,7 +4192,7 @@
                 </a:solidFill>
                 <a:latin typeface="Century Gothic"/>
               </a:rPr>
-              <a:t>PACKET P. 4 · BOX 05</a:t>
+              <a:t>PACKET P. 5 · BOX 05</a:t>
             </a:r>
           </a:p>
         </p:txBody>
@@ -7490,7 +7490,7 @@
                 </a:solidFill>
                 <a:latin typeface="Century Gothic"/>
               </a:rPr>
-              <a:t>PACKET P. 1 · BOX 02</a:t>
+              <a:t>PACKET PP. 1–2 · BOX 02</a:t>
             </a:r>
           </a:p>
         </p:txBody>
@@ -9396,7 +9396,7 @@
                 </a:solidFill>
                 <a:latin typeface="Century Gothic"/>
               </a:rPr>
-              <a:t>PACKET P. 1 · PURPLE STRIP</a:t>
+              <a:t>PACKET P. 2 · PURPLE STRIP</a:t>
             </a:r>
           </a:p>
         </p:txBody>
@@ -11283,7 +11283,7 @@
                 </a:solidFill>
                 <a:latin typeface="Century Gothic"/>
               </a:rPr>
-              <a:t>PACKET P. 2 · BOX 03</a:t>
+              <a:t>PACKET P. 3 · BOX 03</a:t>
             </a:r>
           </a:p>
         </p:txBody>

</xml_diff>